<commit_message>
Update project pipeline and documentation
Co-authored-by: Copilot <223556219+Copilot@users.noreply.github.com>
</commit_message>
<xml_diff>
--- a/docs/slide.pptx
+++ b/docs/slide.pptx
@@ -3701,7 +3701,7 @@
                 <a:ea typeface="Arial" panose="020B0604020202020204"/>
                 <a:cs typeface="Arial" panose="020B0604020202020204"/>
               </a:rPr>
-              <a:t>version 1.0.0</a:t>
+              <a:t>version 2.0.0</a:t>
             </a:r>
             <a:endParaRPr sz="900" b="1">
               <a:solidFill>
@@ -4761,7 +4761,7 @@
                 <a:ea typeface="Arial" panose="020B0604020202020204"/>
                 <a:cs typeface="Arial" panose="020B0604020202020204"/>
               </a:rPr>
-              <a:t>Metadata artifact: 24/09/2026</a:t>
+              <a:t>Metadata artifact: 01/10/2026</a:t>
             </a:r>
             <a:endParaRPr sz="900" b="0">
               <a:solidFill>

</xml_diff>

<commit_message>
docs: finalize report and presentation
Co-authored-by: Copilot <223556219+Copilot@users.noreply.github.com>
</commit_message>
<xml_diff>
--- a/docs/slide.pptx
+++ b/docs/slide.pptx
@@ -312,16 +312,16 @@
                 <c:formatCode>General</c:formatCode>
                 <c:ptCount val="4"/>
                 <c:pt idx="0">
-                  <c:v>46839.74</c:v>
+                  <c:v>46387.57</c:v>
                 </c:pt>
                 <c:pt idx="1">
-                  <c:v>50180.69</c:v>
+                  <c:v>49697.39</c:v>
                 </c:pt>
                 <c:pt idx="2">
-                  <c:v>62657.82</c:v>
+                  <c:v>60797.85</c:v>
                 </c:pt>
                 <c:pt idx="3">
-                  <c:v>72701.33</c:v>
+                  <c:v>69127.04</c:v>
                 </c:pt>
               </c:numCache>
             </c:numRef>
@@ -3121,7 +3121,7 @@
               </a:defRPr>
             </a:pPr>
             <a:r>
-              <a:rPr sz="825" b="0">
+              <a:rPr lang="vi-VN" sz="825" b="0">
                 <a:solidFill>
                   <a:srgbClr val="D9E3EC"/>
                 </a:solidFill>
@@ -3129,9 +3129,9 @@
                 <a:ea typeface="Arial" panose="020B0604020202020204"/>
                 <a:cs typeface="Arial" panose="020B0604020202020204"/>
               </a:rPr>
-              <a:t>Nguồn hình: ai-models/notebooks/ML_Project.ipynb</a:t>
-            </a:r>
-            <a:endParaRPr sz="825" b="0">
+              <a:t>Tham chiếu: README.md · báo cáo bài tập lớn</a:t>
+            </a:r>
+            <a:endParaRPr lang="vi-VN" sz="825" b="0">
               <a:solidFill>
                 <a:srgbClr val="D9E3EC"/>
               </a:solidFill>
@@ -4842,7 +4842,7 @@
               </a:defRPr>
             </a:pPr>
             <a:r>
-              <a:rPr sz="825" b="0">
+              <a:rPr lang="vi-VN" sz="825" b="0">
                 <a:solidFill>
                   <a:srgbClr val="5F6C7B"/>
                 </a:solidFill>
@@ -4850,9 +4850,9 @@
                 <a:ea typeface="Arial" panose="020B0604020202020204"/>
                 <a:cs typeface="Arial" panose="020B0604020202020204"/>
               </a:rPr>
-              <a:t>Nguồn: ai-models/models/model.joblib; metadata.json; ML_Project.ipynb</a:t>
-            </a:r>
-            <a:endParaRPr sz="825" b="0">
+              <a:t>Nguồn: ai-models/models/model.joblib; metadata.json; ai-models/colab/04_evaluate.ipynb</a:t>
+            </a:r>
+            <a:endParaRPr lang="vi-VN" sz="825" b="0">
               <a:solidFill>
                 <a:srgbClr val="5F6C7B"/>
               </a:solidFill>
@@ -6608,7 +6608,7 @@
               </a:defRPr>
             </a:pPr>
             <a:r>
-              <a:rPr sz="825" b="0">
+              <a:rPr lang="vi-VN" sz="825" b="0">
                 <a:solidFill>
                   <a:srgbClr val="5F6C7B"/>
                 </a:solidFill>
@@ -6616,9 +6616,9 @@
                 <a:ea typeface="Arial" panose="020B0604020202020204"/>
                 <a:cs typeface="Arial" panose="020B0604020202020204"/>
               </a:rPr>
-              <a:t>Nguồn: docker-compose.yml; frontend/app/main.py; backend/app/main.py; ai-service/app/main.py</a:t>
-            </a:r>
-            <a:endParaRPr sz="825" b="0">
+              <a:t>Nguồn: docker-compose.yml; app/frontend/main.py; app/backend/main.py; ai-models/service/main.py</a:t>
+            </a:r>
+            <a:endParaRPr lang="vi-VN" sz="825" b="0">
               <a:solidFill>
                 <a:srgbClr val="5F6C7B"/>
               </a:solidFill>
@@ -8614,7 +8614,7 @@
               </a:defRPr>
             </a:pPr>
             <a:r>
-              <a:rPr sz="825" b="0">
+              <a:rPr lang="vi-VN" sz="825" b="0">
                 <a:solidFill>
                   <a:srgbClr val="5F6C7B"/>
                 </a:solidFill>
@@ -8622,9 +8622,9 @@
                 <a:ea typeface="Arial" panose="020B0604020202020204"/>
                 <a:cs typeface="Arial" panose="020B0604020202020204"/>
               </a:rPr>
-              <a:t>Nguồn: frontend/app/main.py; backend/app/main.py; backend/app/services/ai_client.py</a:t>
-            </a:r>
-            <a:endParaRPr sz="825" b="0">
+              <a:t>Nguồn: app/frontend/main.py; app/backend/main.py; ai-models/service/main.py</a:t>
+            </a:r>
+            <a:endParaRPr lang="vi-VN" sz="825" b="0">
               <a:solidFill>
                 <a:srgbClr val="5F6C7B"/>
               </a:solidFill>
@@ -9125,7 +9125,7 @@
               </a:defRPr>
             </a:pPr>
             <a:r>
-              <a:rPr sz="975" b="1">
+              <a:rPr lang="vi-VN" sz="975" b="1">
                 <a:solidFill>
                   <a:srgbClr val="FFFFFF"/>
                 </a:solidFill>
@@ -9133,9 +9133,9 @@
                 <a:ea typeface="Arial" panose="020B0604020202020204"/>
                 <a:cs typeface="Arial" panose="020B0604020202020204"/>
               </a:rPr>
-              <a:t>Build / image</a:t>
-            </a:r>
-            <a:endParaRPr sz="975" b="1">
+              <a:t>Dockerfile / image</a:t>
+            </a:r>
+            <a:endParaRPr lang="vi-VN" sz="975" b="1">
               <a:solidFill>
                 <a:srgbClr val="FFFFFF"/>
               </a:solidFill>
@@ -9329,7 +9329,7 @@
               </a:defRPr>
             </a:pPr>
             <a:r>
-              <a:rPr sz="1125" b="0">
+              <a:rPr lang="vi-VN" sz="1125" b="0">
                 <a:solidFill>
                   <a:srgbClr val="1D2939"/>
                 </a:solidFill>
@@ -9337,9 +9337,9 @@
                 <a:ea typeface="Arial" panose="020B0604020202020204"/>
                 <a:cs typeface="Arial" panose="020B0604020202020204"/>
               </a:rPr>
-              <a:t>./frontend</a:t>
-            </a:r>
-            <a:endParaRPr sz="1125" b="0">
+              <a:t>./app/frontend/Dockerfile</a:t>
+            </a:r>
+            <a:endParaRPr lang="vi-VN" sz="1125" b="0">
               <a:solidFill>
                 <a:srgbClr val="1D2939"/>
               </a:solidFill>
@@ -9533,7 +9533,7 @@
               </a:defRPr>
             </a:pPr>
             <a:r>
-              <a:rPr sz="1125" b="0">
+              <a:rPr lang="vi-VN" sz="1125" b="0">
                 <a:solidFill>
                   <a:srgbClr val="1D2939"/>
                 </a:solidFill>
@@ -9541,9 +9541,9 @@
                 <a:ea typeface="Arial" panose="020B0604020202020204"/>
                 <a:cs typeface="Arial" panose="020B0604020202020204"/>
               </a:rPr>
-              <a:t>./backend</a:t>
-            </a:r>
-            <a:endParaRPr sz="1125" b="0">
+              <a:t>./app/backend/Dockerfile</a:t>
+            </a:r>
+            <a:endParaRPr lang="vi-VN" sz="1125" b="0">
               <a:solidFill>
                 <a:srgbClr val="1D2939"/>
               </a:solidFill>
@@ -9737,7 +9737,7 @@
               </a:defRPr>
             </a:pPr>
             <a:r>
-              <a:rPr sz="1125" b="0">
+              <a:rPr lang="vi-VN" sz="1125" b="0">
                 <a:solidFill>
                   <a:srgbClr val="1D2939"/>
                 </a:solidFill>
@@ -9745,9 +9745,9 @@
                 <a:ea typeface="Arial" panose="020B0604020202020204"/>
                 <a:cs typeface="Arial" panose="020B0604020202020204"/>
               </a:rPr>
-              <a:t>./ai-service</a:t>
-            </a:r>
-            <a:endParaRPr sz="1125" b="0">
+              <a:t>./ai-models/service/Dockerfile</a:t>
+            </a:r>
+            <a:endParaRPr lang="vi-VN" sz="1125" b="0">
               <a:solidFill>
                 <a:srgbClr val="1D2939"/>
               </a:solidFill>
@@ -9941,7 +9941,7 @@
               </a:defRPr>
             </a:pPr>
             <a:r>
-              <a:rPr sz="1125" b="0">
+              <a:rPr lang="vi-VN" sz="1125" b="0">
                 <a:solidFill>
                   <a:srgbClr val="1D2939"/>
                 </a:solidFill>
@@ -9949,9 +9949,9 @@
                 <a:ea typeface="Arial" panose="020B0604020202020204"/>
                 <a:cs typeface="Arial" panose="020B0604020202020204"/>
               </a:rPr>
-              <a:t>mongo</a:t>
-            </a:r>
-            <a:endParaRPr sz="1125" b="0">
+              <a:t>mongo:7</a:t>
+            </a:r>
+            <a:endParaRPr lang="vi-VN" sz="1125" b="0">
               <a:solidFill>
                 <a:srgbClr val="1D2939"/>
               </a:solidFill>
@@ -10349,7 +10349,7 @@
               </a:defRPr>
             </a:pPr>
             <a:r>
-              <a:rPr sz="1725" b="1">
+              <a:rPr lang="vi-VN" sz="1725" b="1">
                 <a:solidFill>
                   <a:srgbClr val="B54736"/>
                 </a:solidFill>
@@ -10357,9 +10357,9 @@
                 <a:ea typeface="Arial" panose="020B0604020202020204"/>
                 <a:cs typeface="Arial" panose="020B0604020202020204"/>
               </a:rPr>
-              <a:t>Chưa xác minh end-to-end</a:t>
-            </a:r>
-            <a:endParaRPr sz="1725" b="1">
+              <a:t>Local end-to-end đã xác minh</a:t>
+            </a:r>
+            <a:endParaRPr lang="vi-VN" sz="1725" b="1">
               <a:solidFill>
                 <a:srgbClr val="B54736"/>
               </a:solidFill>
@@ -10413,7 +10413,7 @@
               </a:defRPr>
             </a:pPr>
             <a:r>
-              <a:rPr sz="1125" b="0">
+              <a:rPr lang="vi-VN" sz="1125" b="0">
                 <a:solidFill>
                   <a:srgbClr val="5F6C7B"/>
                 </a:solidFill>
@@ -10421,9 +10421,9 @@
                 <a:ea typeface="Arial" panose="020B0604020202020204"/>
                 <a:cs typeface="Arial" panose="020B0604020202020204"/>
               </a:rPr>
-              <a:t>Docker CLI có sẵn nhưng daemon không chạy trong lúc kiểm tra.</a:t>
-            </a:r>
-            <a:endParaRPr sz="1125" b="0">
+              <a:t>4 container khỏe; health FE/BE/AI HTTP 200; MongoDB connected.</a:t>
+            </a:r>
+            <a:endParaRPr lang="vi-VN" sz="1125" b="0">
               <a:solidFill>
                 <a:srgbClr val="5F6C7B"/>
               </a:solidFill>
@@ -10582,7 +10582,7 @@
               </a:defRPr>
             </a:pPr>
             <a:r>
-              <a:rPr sz="1725" b="1">
+              <a:rPr lang="vi-VN" sz="1725" b="1">
                 <a:solidFill>
                   <a:srgbClr val="FFFFFF"/>
                 </a:solidFill>
@@ -10590,9 +10590,9 @@
                 <a:ea typeface="Arial" panose="020B0604020202020204"/>
                 <a:cs typeface="Arial" panose="020B0604020202020204"/>
               </a:rPr>
-              <a:t>Đang chuẩn bị · URL public: CHƯA CÓ</a:t>
-            </a:r>
-            <a:endParaRPr sz="1725" b="1">
+              <a:t>Tunnel ngrok tạm thời · xác minh URL trước demo.</a:t>
+            </a:r>
+            <a:endParaRPr lang="vi-VN" sz="1725" b="1">
               <a:solidFill>
                 <a:srgbClr val="FFFFFF"/>
               </a:solidFill>
@@ -11430,7 +11430,7 @@
               </a:defRPr>
             </a:pPr>
             <a:r>
-              <a:rPr sz="900" b="0">
+              <a:rPr lang="vi-VN" sz="900" b="0">
                 <a:solidFill>
                   <a:srgbClr val="5F6C7B"/>
                 </a:solidFill>
@@ -11438,9 +11438,9 @@
                 <a:ea typeface="Arial" panose="020B0604020202020204"/>
                 <a:cs typeface="Arial" panose="020B0604020202020204"/>
               </a:rPr>
-              <a:t>health + predict qua HTTP cục bộ</a:t>
-            </a:r>
-            <a:endParaRPr sz="900" b="0">
+              <a:t>health + predict + history qua Docker Compose</a:t>
+            </a:r>
+            <a:endParaRPr lang="vi-VN" sz="900" b="0">
               <a:solidFill>
                 <a:srgbClr val="5F6C7B"/>
               </a:solidFill>
@@ -11560,7 +11560,7 @@
               </a:defRPr>
             </a:pPr>
             <a:r>
-              <a:rPr sz="2250" b="1">
+              <a:rPr lang="vi-VN" sz="2250" b="1">
                 <a:solidFill>
                   <a:srgbClr val="102A43"/>
                 </a:solidFill>
@@ -11568,9 +11568,9 @@
                 <a:ea typeface="Arial" panose="020B0604020202020204"/>
                 <a:cs typeface="Arial" panose="020B0604020202020204"/>
               </a:rPr>
-              <a:t>262.225,38</a:t>
-            </a:r>
-            <a:endParaRPr sz="2250" b="1">
+              <a:t>HTTP 200</a:t>
+            </a:r>
+            <a:endParaRPr lang="vi-VN" sz="2250" b="1">
               <a:solidFill>
                 <a:srgbClr val="102A43"/>
               </a:solidFill>
@@ -11624,7 +11624,7 @@
               </a:defRPr>
             </a:pPr>
             <a:r>
-              <a:rPr sz="1125" b="1">
+              <a:rPr lang="vi-VN" sz="1125" b="1">
                 <a:solidFill>
                   <a:srgbClr val="5F6C7B"/>
                 </a:solidFill>
@@ -11632,9 +11632,9 @@
                 <a:ea typeface="Arial" panose="020B0604020202020204"/>
                 <a:cs typeface="Arial" panose="020B0604020202020204"/>
               </a:rPr>
-              <a:t>Prediction mẫu (USD)</a:t>
-            </a:r>
-            <a:endParaRPr sz="1125" b="1">
+              <a:t>FE/BE/AI /health</a:t>
+            </a:r>
+            <a:endParaRPr lang="vi-VN" sz="1125" b="1">
               <a:solidFill>
                 <a:srgbClr val="5F6C7B"/>
               </a:solidFill>
@@ -11688,7 +11688,7 @@
               </a:defRPr>
             </a:pPr>
             <a:r>
-              <a:rPr sz="900" b="0">
+              <a:rPr lang="vi-VN" sz="900" b="0">
                 <a:solidFill>
                   <a:srgbClr val="5F6C7B"/>
                 </a:solidFill>
@@ -11696,9 +11696,9 @@
                 <a:ea typeface="Arial" panose="020B0604020202020204"/>
                 <a:cs typeface="Arial" panose="020B0604020202020204"/>
               </a:rPr>
-              <a:t>model_version 1.0.0</a:t>
-            </a:r>
-            <a:endParaRPr sz="900" b="0">
+              <a:t>MongoDB: history saved</a:t>
+            </a:r>
+            <a:endParaRPr lang="vi-VN" sz="900" b="0">
               <a:solidFill>
                 <a:srgbClr val="5F6C7B"/>
               </a:solidFill>
@@ -11936,7 +11936,7 @@
               </a:defRPr>
             </a:pPr>
             <a:r>
-              <a:rPr sz="1200">
+              <a:rPr lang="vi-VN" sz="1200">
                 <a:solidFill>
                   <a:srgbClr val="1D2939"/>
                 </a:solidFill>
@@ -11944,7 +11944,7 @@
                 <a:ea typeface="Arial" panose="020B0604020202020204"/>
                 <a:cs typeface="Arial" panose="020B0604020202020204"/>
               </a:rPr>
-              <a:t>Smoke: backend :18000 gọi AI service :18001 thành công.</a:t>
+              <a:t>Compose: FE/BE/AI/MongoDB chạy khỏe trên local.</a:t>
             </a:r>
             <a:endParaRPr sz="1200">
               <a:solidFill>
@@ -11974,7 +11974,7 @@
               </a:defRPr>
             </a:pPr>
             <a:r>
-              <a:rPr sz="1200">
+              <a:rPr lang="vi-VN" sz="1200">
                 <a:solidFill>
                   <a:srgbClr val="1D2939"/>
                 </a:solidFill>
@@ -11982,9 +11982,9 @@
                 <a:ea typeface="Arial" panose="020B0604020202020204"/>
                 <a:cs typeface="Arial" panose="020B0604020202020204"/>
               </a:rPr>
-              <a:t>Response chứa prediction, model_version và request_id.</a:t>
-            </a:r>
-            <a:endParaRPr sz="1200">
+              <a:t>Prediction đã lưu được vào history trên stack local.</a:t>
+            </a:r>
+            <a:endParaRPr lang="vi-VN" sz="1200">
               <a:solidFill>
                 <a:srgbClr val="1D2939"/>
               </a:solidFill>
@@ -12146,7 +12146,7 @@
               </a:defRPr>
             </a:pPr>
             <a:r>
-              <a:rPr sz="1200">
+              <a:rPr lang="vi-VN" sz="1200">
                 <a:solidFill>
                   <a:srgbClr val="1D2939"/>
                 </a:solidFill>
@@ -12154,7 +12154,7 @@
                 <a:ea typeface="Arial" panose="020B0604020202020204"/>
                 <a:cs typeface="Arial" panose="020B0604020202020204"/>
               </a:rPr>
-              <a:t>MongoDB không chạy trong smoke test.</a:t>
+              <a:t>Public tunnel ngrok tạm thời, phụ thuộc máy host.</a:t>
             </a:r>
             <a:endParaRPr sz="1200">
               <a:solidFill>
@@ -12184,7 +12184,7 @@
               </a:defRPr>
             </a:pPr>
             <a:r>
-              <a:rPr sz="1200">
+              <a:rPr lang="vi-VN" sz="1200">
                 <a:solidFill>
                   <a:srgbClr val="1D2939"/>
                 </a:solidFill>
@@ -12192,7 +12192,7 @@
                 <a:ea typeface="Arial" panose="020B0604020202020204"/>
                 <a:cs typeface="Arial" panose="020B0604020202020204"/>
               </a:rPr>
-              <a:t>API vẫn trả 200; lưu lịch sử báo lỗi kết nối.</a:t>
+              <a:t>URL ngrok cần được xác minh lại trước demo.</a:t>
             </a:r>
             <a:endParaRPr sz="1200">
               <a:solidFill>
@@ -12222,7 +12222,7 @@
               </a:defRPr>
             </a:pPr>
             <a:r>
-              <a:rPr sz="1200">
+              <a:rPr lang="vi-VN" sz="1200">
                 <a:solidFill>
                   <a:srgbClr val="1D2939"/>
                 </a:solidFill>
@@ -12230,7 +12230,7 @@
                 <a:ea typeface="Arial" panose="020B0604020202020204"/>
                 <a:cs typeface="Arial" panose="020B0604020202020204"/>
               </a:rPr>
-              <a:t>Chưa xác minh endpoint history với dữ liệu thật.</a:t>
+              <a:t>API hiện chưa có authentication/authorization.</a:t>
             </a:r>
             <a:endParaRPr sz="1200">
               <a:solidFill>
@@ -12260,7 +12260,7 @@
               </a:defRPr>
             </a:pPr>
             <a:r>
-              <a:rPr sz="1200">
+              <a:rPr lang="vi-VN" sz="1200">
                 <a:solidFill>
                   <a:srgbClr val="1D2939"/>
                 </a:solidFill>
@@ -12268,9 +12268,9 @@
                 <a:ea typeface="Arial" panose="020B0604020202020204"/>
                 <a:cs typeface="Arial" panose="020B0604020202020204"/>
               </a:rPr>
-              <a:t>Mỗi nhóm test có 1 warning deprecation từ thư viện.</a:t>
-            </a:r>
-            <a:endParaRPr sz="1200">
+              <a:t>Load test đo local, không đại diện cho public host.</a:t>
+            </a:r>
+            <a:endParaRPr lang="vi-VN" sz="1200">
               <a:solidFill>
                 <a:srgbClr val="1D2939"/>
               </a:solidFill>
@@ -12349,7 +12349,7 @@
               </a:defRPr>
             </a:pPr>
             <a:r>
-              <a:rPr sz="825" b="0">
+              <a:rPr lang="vi-VN" sz="825" b="0">
                 <a:solidFill>
                   <a:srgbClr val="5F6C7B"/>
                 </a:solidFill>
@@ -12357,9 +12357,9 @@
                 <a:ea typeface="Arial" panose="020B0604020202020204"/>
                 <a:cs typeface="Arial" panose="020B0604020202020204"/>
               </a:rPr>
-              <a:t>Nguồn: ai-service/tests; backend/tests; tests/smoke/smoke_test.py; log chạy 27/09/2026</a:t>
-            </a:r>
-            <a:endParaRPr sz="825" b="0">
+              <a:t>Nguồn: ai-models/service/tests; app/backend/tests; docs/deployment_log.md (02/10/2026)</a:t>
+            </a:r>
+            <a:endParaRPr lang="vi-VN" sz="825" b="0">
               <a:solidFill>
                 <a:srgbClr val="5F6C7B"/>
               </a:solidFill>
@@ -12697,7 +12697,7 @@
               </a:defRPr>
             </a:pPr>
             <a:r>
-              <a:rPr sz="1875" b="1">
+              <a:rPr lang="vi-VN" sz="1875" b="1">
                 <a:solidFill>
                   <a:srgbClr val="102A43"/>
                 </a:solidFill>
@@ -12705,9 +12705,9 @@
                 <a:ea typeface="Arial" panose="020B0604020202020204"/>
                 <a:cs typeface="Arial" panose="020B0604020202020204"/>
               </a:rPr>
-              <a:t>Kịch bản k6 đã có</a:t>
-            </a:r>
-            <a:endParaRPr sz="1875" b="1">
+              <a:t>Load test API qua Frontend</a:t>
+            </a:r>
+            <a:endParaRPr lang="vi-VN" sz="1875" b="1">
               <a:solidFill>
                 <a:srgbClr val="102A43"/>
               </a:solidFill>
@@ -13441,7 +13441,7 @@
               </a:defRPr>
             </a:pPr>
             <a:r>
-              <a:rPr sz="975" b="0">
+              <a:rPr lang="vi-VN" sz="975" b="0">
                 <a:solidFill>
                   <a:srgbClr val="5F6C7B"/>
                 </a:solidFill>
@@ -13449,9 +13449,9 @@
                 <a:ea typeface="Arial" panose="020B0604020202020204"/>
                 <a:cs typeface="Arial" panose="020B0604020202020204"/>
               </a:rPr>
-              <a:t>File: tests/load/predict.js</a:t>
-            </a:r>
-            <a:endParaRPr sz="975" b="0">
+              <a:t>File: scripts/load_test.ps1</a:t>
+            </a:r>
+            <a:endParaRPr lang="vi-VN" sz="975" b="0">
               <a:solidFill>
                 <a:srgbClr val="5F6C7B"/>
               </a:solidFill>
@@ -13546,7 +13546,7 @@
               </a:defRPr>
             </a:pPr>
             <a:r>
-              <a:rPr sz="1875" b="1">
+              <a:rPr lang="vi-VN" sz="1875" b="1">
                 <a:solidFill>
                   <a:srgbClr val="102A43"/>
                 </a:solidFill>
@@ -13554,9 +13554,9 @@
                 <a:ea typeface="Arial" panose="020B0604020202020204"/>
                 <a:cs typeface="Arial" panose="020B0604020202020204"/>
               </a:rPr>
-              <a:t>Kết quả thực tế</a:t>
-            </a:r>
-            <a:endParaRPr sz="1875" b="1">
+              <a:t>Requests thành công</a:t>
+            </a:r>
+            <a:endParaRPr lang="vi-VN" sz="1875" b="1">
               <a:solidFill>
                 <a:srgbClr val="102A43"/>
               </a:solidFill>
@@ -13610,7 +13610,7 @@
               </a:defRPr>
             </a:pPr>
             <a:r>
-              <a:rPr sz="2850" b="1">
+              <a:rPr lang="vi-VN" sz="2850" b="1">
                 <a:solidFill>
                   <a:srgbClr val="B54736"/>
                 </a:solidFill>
@@ -13618,9 +13618,9 @@
                 <a:ea typeface="Arial" panose="020B0604020202020204"/>
                 <a:cs typeface="Arial" panose="020B0604020202020204"/>
               </a:rPr>
-              <a:t>CHƯA CÓ</a:t>
-            </a:r>
-            <a:endParaRPr sz="2850" b="1">
+              <a:t>2.062</a:t>
+            </a:r>
+            <a:endParaRPr lang="vi-VN" sz="2850" b="1">
               <a:solidFill>
                 <a:srgbClr val="B54736"/>
               </a:solidFill>
@@ -13677,7 +13677,7 @@
               </a:defRPr>
             </a:pPr>
             <a:r>
-              <a:rPr sz="1350">
+              <a:rPr lang="vi-VN" sz="1350">
                 <a:solidFill>
                   <a:srgbClr val="1D2939"/>
                 </a:solidFill>
@@ -13685,7 +13685,7 @@
                 <a:ea typeface="Arial" panose="020B0604020202020204"/>
                 <a:cs typeface="Arial" panose="020B0604020202020204"/>
               </a:rPr>
-              <a:t>k6 chưa được cài trên môi trường kiểm tra.</a:t>
+              <a:t>10 users · 60s cấu hình · 0 lỗi.</a:t>
             </a:r>
             <a:endParaRPr sz="1350">
               <a:solidFill>
@@ -13715,7 +13715,7 @@
               </a:defRPr>
             </a:pPr>
             <a:r>
-              <a:rPr sz="1350">
+              <a:rPr lang="vi-VN" sz="1350">
                 <a:solidFill>
                   <a:srgbClr val="1D2939"/>
                 </a:solidFill>
@@ -13723,7 +13723,7 @@
                 <a:ea typeface="Arial" panose="020B0604020202020204"/>
                 <a:cs typeface="Arial" panose="020B0604020202020204"/>
               </a:rPr>
-              <a:t>p50 / p95 / throughput: chưa đo.</a:t>
+              <a:t>26,67 req/s · p50 261,49 ms · p95 339,08 ms.</a:t>
             </a:r>
             <a:endParaRPr sz="1350">
               <a:solidFill>
@@ -13753,7 +13753,7 @@
               </a:defRPr>
             </a:pPr>
             <a:r>
-              <a:rPr sz="1350">
+              <a:rPr lang="vi-VN" sz="1350">
                 <a:solidFill>
                   <a:srgbClr val="1D2939"/>
                 </a:solidFill>
@@ -13761,7 +13761,7 @@
                 <a:ea typeface="Arial" panose="020B0604020202020204"/>
                 <a:cs typeface="Arial" panose="020B0604020202020204"/>
               </a:rPr>
-              <a:t>Lighthouse frontend: chưa đo.</a:t>
+              <a:t>Error rate 0% · ngưỡng p95 &lt; 2.000 ms: PASS.</a:t>
             </a:r>
             <a:endParaRPr sz="1350">
               <a:solidFill>
@@ -13791,7 +13791,7 @@
               </a:defRPr>
             </a:pPr>
             <a:r>
-              <a:rPr sz="1350">
+              <a:rPr lang="vi-VN" sz="1350">
                 <a:solidFill>
                   <a:srgbClr val="1D2939"/>
                 </a:solidFill>
@@ -13799,9 +13799,9 @@
                 <a:ea typeface="Arial" panose="020B0604020202020204"/>
                 <a:cs typeface="Arial" panose="020B0604020202020204"/>
               </a:rPr>
-              <a:t>docs/performance-test.md hiện vẫn là TBD.</a:t>
-            </a:r>
-            <a:endParaRPr sz="1350">
+              <a:t>Đo local, không đại diện hiệu năng trên public host.</a:t>
+            </a:r>
+            <a:endParaRPr lang="vi-VN" sz="1350">
               <a:solidFill>
                 <a:srgbClr val="1D2939"/>
               </a:solidFill>
@@ -13896,7 +13896,7 @@
               </a:defRPr>
             </a:pPr>
             <a:r>
-              <a:rPr sz="1125" b="1">
+              <a:rPr lang="vi-VN" sz="1125" b="1">
                 <a:solidFill>
                   <a:srgbClr val="102A43"/>
                 </a:solidFill>
@@ -13904,9 +13904,9 @@
                 <a:ea typeface="Arial" panose="020B0604020202020204"/>
                 <a:cs typeface="Arial" panose="020B0604020202020204"/>
               </a:rPr>
-              <a:t>Không suy diễn số liệu khi chưa chạy benchmark.</a:t>
-            </a:r>
-            <a:endParaRPr sz="1125" b="1">
+              <a:t>Thời gian đo thực tế: 77,32 giây.</a:t>
+            </a:r>
+            <a:endParaRPr lang="vi-VN" sz="1125" b="1">
               <a:solidFill>
                 <a:srgbClr val="102A43"/>
               </a:solidFill>
@@ -13985,7 +13985,7 @@
               </a:defRPr>
             </a:pPr>
             <a:r>
-              <a:rPr sz="825" b="0">
+              <a:rPr lang="vi-VN" sz="825" b="0">
                 <a:solidFill>
                   <a:srgbClr val="5F6C7B"/>
                 </a:solidFill>
@@ -13993,9 +13993,9 @@
                 <a:ea typeface="Arial" panose="020B0604020202020204"/>
                 <a:cs typeface="Arial" panose="020B0604020202020204"/>
               </a:rPr>
-              <a:t>Nguồn: tests/load/predict.js; docs/performance-test.md</a:t>
-            </a:r>
-            <a:endParaRPr sz="825" b="0">
+              <a:t>Nguồn: docs/load_test_results.md; scripts/load_test.ps1</a:t>
+            </a:r>
+            <a:endParaRPr lang="vi-VN" sz="825" b="0">
               <a:solidFill>
                 <a:srgbClr val="5F6C7B"/>
               </a:solidFill>
@@ -14552,7 +14552,7 @@
               </a:defRPr>
             </a:pPr>
             <a:r>
-              <a:rPr sz="1275">
+              <a:rPr lang="vi-VN" sz="1275">
                 <a:solidFill>
                   <a:srgbClr val="1D2939"/>
                 </a:solidFill>
@@ -14560,9 +14560,9 @@
                 <a:ea typeface="Arial" panose="020B0604020202020204"/>
                 <a:cs typeface="Arial" panose="020B0604020202020204"/>
               </a:rPr>
-              <a:t>12/12 pytest + smoke PASS</a:t>
-            </a:r>
-            <a:endParaRPr sz="1275">
+              <a:t>Docker Compose + load test local PASS</a:t>
+            </a:r>
+            <a:endParaRPr lang="vi-VN" sz="1275">
               <a:solidFill>
                 <a:srgbClr val="1D2939"/>
               </a:solidFill>
@@ -14749,7 +14749,7 @@
               </a:defRPr>
             </a:pPr>
             <a:r>
-              <a:rPr sz="1275">
+              <a:rPr lang="vi-VN" sz="1275">
                 <a:solidFill>
                   <a:srgbClr val="1D2939"/>
                 </a:solidFill>
@@ -14757,7 +14757,7 @@
                 <a:ea typeface="Arial" panose="020B0604020202020204"/>
                 <a:cs typeface="Arial" panose="020B0604020202020204"/>
               </a:rPr>
-              <a:t>Chưa có URL public</a:t>
+              <a:t>Ngrok tạm thời · URL cần xác minh</a:t>
             </a:r>
             <a:endParaRPr sz="1275">
               <a:solidFill>
@@ -14787,7 +14787,7 @@
               </a:defRPr>
             </a:pPr>
             <a:r>
-              <a:rPr sz="1275">
+              <a:rPr lang="vi-VN" sz="1275">
                 <a:solidFill>
                   <a:srgbClr val="1D2939"/>
                 </a:solidFill>
@@ -14795,7 +14795,7 @@
                 <a:ea typeface="Arial" panose="020B0604020202020204"/>
                 <a:cs typeface="Arial" panose="020B0604020202020204"/>
               </a:rPr>
-              <a:t>Docker runtime chưa xác minh</a:t>
+              <a:t>API chưa có authentication</a:t>
             </a:r>
             <a:endParaRPr sz="1275">
               <a:solidFill>
@@ -14825,7 +14825,7 @@
               </a:defRPr>
             </a:pPr>
             <a:r>
-              <a:rPr sz="1275">
+              <a:rPr lang="vi-VN" sz="1275">
                 <a:solidFill>
                   <a:srgbClr val="1D2939"/>
                 </a:solidFill>
@@ -14833,7 +14833,7 @@
                 <a:ea typeface="Arial" panose="020B0604020202020204"/>
                 <a:cs typeface="Arial" panose="020B0604020202020204"/>
               </a:rPr>
-              <a:t>Mongo history chưa test thật</a:t>
+              <a:t>Notebook/artifact metrics khác nhau</a:t>
             </a:r>
             <a:endParaRPr sz="1275">
               <a:solidFill>
@@ -14863,7 +14863,7 @@
               </a:defRPr>
             </a:pPr>
             <a:r>
-              <a:rPr sz="1275">
+              <a:rPr lang="vi-VN" sz="1275">
                 <a:solidFill>
                   <a:srgbClr val="1D2939"/>
                 </a:solidFill>
@@ -14871,7 +14871,7 @@
                 <a:ea typeface="Arial" panose="020B0604020202020204"/>
                 <a:cs typeface="Arial" panose="020B0604020202020204"/>
               </a:rPr>
-              <a:t>Chưa có k6 / Lighthouse</a:t>
+              <a:t>Load test chỉ đo local</a:t>
             </a:r>
             <a:endParaRPr sz="1275">
               <a:solidFill>
@@ -15098,7 +15098,7 @@
               </a:defRPr>
             </a:pPr>
             <a:r>
-              <a:rPr sz="1275">
+              <a:rPr lang="vi-VN" sz="1275">
                 <a:solidFill>
                   <a:srgbClr val="1D2939"/>
                 </a:solidFill>
@@ -15106,7 +15106,7 @@
                 <a:ea typeface="Arial" panose="020B0604020202020204"/>
                 <a:cs typeface="Arial" panose="020B0604020202020204"/>
               </a:rPr>
-              <a:t>Chạy Compose end-to-end</a:t>
+              <a:t>Hosting ổn định + URL mới</a:t>
             </a:r>
             <a:endParaRPr sz="1275">
               <a:solidFill>
@@ -15136,7 +15136,7 @@
               </a:defRPr>
             </a:pPr>
             <a:r>
-              <a:rPr sz="1275">
+              <a:rPr lang="vi-VN" sz="1275">
                 <a:solidFill>
                   <a:srgbClr val="1D2939"/>
                 </a:solidFill>
@@ -15144,7 +15144,7 @@
                 <a:ea typeface="Arial" panose="020B0604020202020204"/>
                 <a:cs typeface="Arial" panose="020B0604020202020204"/>
               </a:rPr>
-              <a:t>Đo load và frontend</a:t>
+              <a:t>Benchmark trên host deploy</a:t>
             </a:r>
             <a:endParaRPr sz="1275">
               <a:solidFill>
@@ -15174,7 +15174,7 @@
               </a:defRPr>
             </a:pPr>
             <a:r>
-              <a:rPr sz="1275">
+              <a:rPr lang="vi-VN" sz="1275">
                 <a:solidFill>
                   <a:srgbClr val="1D2939"/>
                 </a:solidFill>
@@ -15182,7 +15182,7 @@
                 <a:ea typeface="Arial" panose="020B0604020202020204"/>
                 <a:cs typeface="Arial" panose="020B0604020202020204"/>
               </a:rPr>
-              <a:t>Pin version dependencies</a:t>
+              <a:t>Bổ sung authentication</a:t>
             </a:r>
             <a:endParaRPr sz="1275">
               <a:solidFill>
@@ -15405,7 +15405,7 @@
               </a:defRPr>
             </a:pPr>
             <a:r>
-              <a:rPr sz="825" b="0">
+              <a:rPr lang="vi-VN" sz="825" b="0">
                 <a:solidFill>
                   <a:srgbClr val="D9E3EC"/>
                 </a:solidFill>
@@ -15413,9 +15413,9 @@
                 <a:ea typeface="Arial" panose="020B0604020202020204"/>
                 <a:cs typeface="Arial" panose="020B0604020202020204"/>
               </a:rPr>
-              <a:t>Tổng hợp từ repository cali-house-price-prediction-git</a:t>
-            </a:r>
-            <a:endParaRPr sz="825" b="0">
+              <a:t>Nguồn: README.md; docs/deployment_log.md; docs/load_test_results.md</a:t>
+            </a:r>
+            <a:endParaRPr lang="vi-VN" sz="825" b="0">
               <a:solidFill>
                 <a:srgbClr val="D9E3EC"/>
               </a:solidFill>
@@ -16828,7 +16828,7 @@
               </a:defRPr>
             </a:pPr>
             <a:r>
-              <a:rPr sz="825" b="0">
+              <a:rPr lang="vi-VN" sz="825" b="0">
                 <a:solidFill>
                   <a:srgbClr val="5F6C7B"/>
                 </a:solidFill>
@@ -16836,9 +16836,9 @@
                 <a:ea typeface="Arial" panose="020B0604020202020204"/>
                 <a:cs typeface="Arial" panose="020B0604020202020204"/>
               </a:rPr>
-              <a:t>Nguồn: ai-models/src/train.py; ai-service/app/schemas.py</a:t>
-            </a:r>
-            <a:endParaRPr sz="825" b="0">
+              <a:t>Nguồn: ai-models/src/train.py; ai-models/service/main.py; ai-models/models/schema.json</a:t>
+            </a:r>
+            <a:endParaRPr lang="vi-VN" sz="825" b="0">
               <a:solidFill>
                 <a:srgbClr val="5F6C7B"/>
               </a:solidFill>
@@ -17975,7 +17975,7 @@
               </a:defRPr>
             </a:pPr>
             <a:r>
-              <a:rPr sz="900" b="0">
+              <a:rPr lang="vi-VN" sz="900" b="0">
                 <a:solidFill>
                   <a:srgbClr val="5F6C7B"/>
                 </a:solidFill>
@@ -17983,9 +17983,9 @@
                 <a:ea typeface="Arial" panose="020B0604020202020204"/>
                 <a:cs typeface="Arial" panose="020B0604020202020204"/>
               </a:rPr>
-              <a:t>Min 14.999 · Median 179.700 · Max 500.001 USD</a:t>
-            </a:r>
-            <a:endParaRPr sz="900" b="0">
+              <a:t>Min 14.999 · Median 179.700 · Trần ~500.000 USD</a:t>
+            </a:r>
+            <a:endParaRPr lang="vi-VN" sz="900" b="0">
               <a:solidFill>
                 <a:srgbClr val="5F6C7B"/>
               </a:solidFill>
@@ -19715,7 +19715,7 @@
               </a:defRPr>
             </a:pPr>
             <a:r>
-              <a:rPr sz="1275">
+              <a:rPr lang="vi-VN" sz="1275">
                 <a:solidFill>
                   <a:srgbClr val="1D2939"/>
                 </a:solidFill>
@@ -19723,7 +19723,7 @@
                 <a:ea typeface="Arial" panose="020B0604020202020204"/>
                 <a:cs typeface="Arial" panose="020B0604020202020204"/>
               </a:rPr>
-              <a:t>median_house_value có trần quan sát 500.001 USD.</a:t>
+              <a:t>median_house_value có trần quan sát quanh 500.000 USD.</a:t>
             </a:r>
             <a:endParaRPr sz="1275">
               <a:solidFill>
@@ -20052,7 +20052,7 @@
               </a:defRPr>
             </a:pPr>
             <a:r>
-              <a:rPr sz="825" b="0">
+              <a:rPr lang="vi-VN" sz="825" b="0">
                 <a:solidFill>
                   <a:srgbClr val="5F6C7B"/>
                 </a:solidFill>
@@ -20060,9 +20060,9 @@
                 <a:ea typeface="Arial" panose="020B0604020202020204"/>
                 <a:cs typeface="Arial" panose="020B0604020202020204"/>
               </a:rPr>
-              <a:t>Nguồn: ai-models/data/housing.csv.zip; ai-models/notebooks/01_eda.ipynb</a:t>
-            </a:r>
-            <a:endParaRPr sz="825" b="0">
+              <a:t>Nguồn: ai-models/data/housing.csv.zip; ai-models/colab/01_eda.ipynb</a:t>
+            </a:r>
+            <a:endParaRPr lang="vi-VN" sz="825" b="0">
               <a:solidFill>
                 <a:srgbClr val="5F6C7B"/>
               </a:solidFill>
@@ -20490,7 +20490,7 @@
               </a:defRPr>
             </a:pPr>
             <a:r>
-              <a:rPr sz="1050" b="0">
+              <a:rPr lang="vi-VN" sz="1050" b="0">
                 <a:solidFill>
                   <a:srgbClr val="5F6C7B"/>
                 </a:solidFill>
@@ -20498,9 +20498,9 @@
                 <a:ea typeface="Arial" panose="020B0604020202020204"/>
                 <a:cs typeface="Arial" panose="020B0604020202020204"/>
               </a:rPr>
-              <a:t>Giá nhà lệch phải; có cụm lớn tại mức trần 500.001 USD.</a:t>
-            </a:r>
-            <a:endParaRPr sz="1050" b="0">
+              <a:t>Giá nhà lệch phải; có cụm lớn tại mức trần quanh 500.000 USD.</a:t>
+            </a:r>
+            <a:endParaRPr lang="vi-VN" sz="1050" b="0">
               <a:solidFill>
                 <a:srgbClr val="5F6C7B"/>
               </a:solidFill>
@@ -20969,7 +20969,7 @@
               </a:defRPr>
             </a:pPr>
             <a:r>
-              <a:rPr sz="825" b="0">
+              <a:rPr lang="vi-VN" sz="825" b="0">
                 <a:solidFill>
                   <a:srgbClr val="5F6C7B"/>
                 </a:solidFill>
@@ -20977,9 +20977,9 @@
                 <a:ea typeface="Arial" panose="020B0604020202020204"/>
                 <a:cs typeface="Arial" panose="020B0604020202020204"/>
               </a:rPr>
-              <a:t>Nguồn hình: ai-models/notebooks/ML_Project.ipynb (output thực tế)</a:t>
-            </a:r>
-            <a:endParaRPr sz="825" b="0">
+              <a:t>Nguồn hình: docs/figures/plot_1, plot_2, plot_3</a:t>
+            </a:r>
+            <a:endParaRPr lang="vi-VN" sz="825" b="0">
               <a:solidFill>
                 <a:srgbClr val="5F6C7B"/>
               </a:solidFill>
@@ -21733,7 +21733,7 @@
               </a:defRPr>
             </a:pPr>
             <a:r>
-              <a:rPr sz="1125" b="0">
+              <a:rPr lang="vi-VN" sz="1125" b="0">
                 <a:solidFill>
                   <a:srgbClr val="5F6C7B"/>
                 </a:solidFill>
@@ -21741,9 +21741,9 @@
                 <a:ea typeface="Arial" panose="020B0604020202020204"/>
                 <a:cs typeface="Arial" panose="020B0604020202020204"/>
               </a:rPr>
-              <a:t>Quan hệ tăng rõ, đồng thời xuất hiện dải trần tại 500.001 USD.</a:t>
-            </a:r>
-            <a:endParaRPr sz="1125" b="0">
+              <a:t>Quan hệ tăng rõ, đồng thời xuất hiện dải trần quanh 500.000 USD.</a:t>
+            </a:r>
+            <a:endParaRPr lang="vi-VN" sz="1125" b="0">
               <a:solidFill>
                 <a:srgbClr val="5F6C7B"/>
               </a:solidFill>
@@ -21886,7 +21886,7 @@
               </a:defRPr>
             </a:pPr>
             <a:r>
-              <a:rPr sz="825" b="0">
+              <a:rPr lang="vi-VN" sz="825" b="0">
                 <a:solidFill>
                   <a:srgbClr val="5F6C7B"/>
                 </a:solidFill>
@@ -21894,9 +21894,9 @@
                 <a:ea typeface="Arial" panose="020B0604020202020204"/>
                 <a:cs typeface="Arial" panose="020B0604020202020204"/>
               </a:rPr>
-              <a:t>Nguồn hình: ai-models/notebooks/ML_Project.ipynb; hệ số tính từ housing.csv.zip</a:t>
-            </a:r>
-            <a:endParaRPr sz="825" b="0">
+              <a:t>Nguồn hình: docs/figures/plot_4, plot_5, plot_6; hệ số từ housing.csv.zip</a:t>
+            </a:r>
+            <a:endParaRPr lang="vi-VN" sz="825" b="0">
               <a:solidFill>
                 <a:srgbClr val="5F6C7B"/>
               </a:solidFill>
@@ -23776,7 +23776,7 @@
               </a:defRPr>
             </a:pPr>
             <a:r>
-              <a:rPr sz="1275" b="0">
+              <a:rPr lang="vi-VN" sz="1275" b="0">
                 <a:solidFill>
                   <a:srgbClr val="1D2939"/>
                 </a:solidFill>
@@ -23784,9 +23784,9 @@
                 <a:ea typeface="Arial" panose="020B0604020202020204"/>
                 <a:cs typeface="Arial" panose="020B0604020202020204"/>
               </a:rPr>
-              <a:t>Bản model lưu gồm preprocessor + model. Median imputer được fit trước pipeline khi train; phía API yêu cầu input đầy đủ và tự tính 3 tỷ lệ trước khi dự đoán.</a:t>
-            </a:r>
-            <a:endParaRPr sz="1275" b="0">
+              <a:t>Artifact lưu preprocessor + model. Pipeline tự impute, tạo 3 tỷ lệ, scale và encode; API nhận 9 đặc trưng gốc để dự đoán.</a:t>
+            </a:r>
+            <a:endParaRPr lang="vi-VN" sz="1275" b="0">
               <a:solidFill>
                 <a:srgbClr val="1D2939"/>
               </a:solidFill>
@@ -23865,7 +23865,7 @@
               </a:defRPr>
             </a:pPr>
             <a:r>
-              <a:rPr sz="825" b="0">
+              <a:rPr lang="vi-VN" sz="825" b="0">
                 <a:solidFill>
                   <a:srgbClr val="5F6C7B"/>
                 </a:solidFill>
@@ -23873,9 +23873,9 @@
                 <a:ea typeface="Arial" panose="020B0604020202020204"/>
                 <a:cs typeface="Arial" panose="020B0604020202020204"/>
               </a:rPr>
-              <a:t>Nguồn: ai-models/src/preprocess.py; ai-models/src/train.py; ai-service/app/model.py</a:t>
-            </a:r>
-            <a:endParaRPr sz="825" b="0">
+              <a:t>Nguồn: ai-models/src/preprocess.py; app/backend/main.py; ai-models/service/main.py</a:t>
+            </a:r>
+            <a:endParaRPr lang="vi-VN" sz="825" b="0">
               <a:solidFill>
                 <a:srgbClr val="5F6C7B"/>
               </a:solidFill>
@@ -26962,7 +26962,7 @@
               </a:defRPr>
             </a:pPr>
             <a:r>
-              <a:rPr sz="1425" b="1">
+              <a:rPr lang="vi-VN" sz="1425" b="1">
                 <a:solidFill>
                   <a:srgbClr val="102A43"/>
                 </a:solidFill>
@@ -26970,9 +26970,9 @@
                 <a:ea typeface="Arial" panose="020B0604020202020204"/>
                 <a:cs typeface="Arial" panose="020B0604020202020204"/>
               </a:rPr>
-              <a:t>Gradient Boosting đứng đầu: CV RMSE 47.197,84 · Test RMSE 46.839,74 · thời gian train 14,08 giây.</a:t>
-            </a:r>
-            <a:endParaRPr sz="1425" b="1">
+              <a:t>Gradient Boosting đứng đầu: CV RMSE 47.251,39 · Test RMSE 46.387,57 USD.</a:t>
+            </a:r>
+            <a:endParaRPr lang="vi-VN" sz="1425" b="1">
               <a:solidFill>
                 <a:srgbClr val="102A43"/>
               </a:solidFill>
@@ -27051,7 +27051,7 @@
               </a:defRPr>
             </a:pPr>
             <a:r>
-              <a:rPr sz="825" b="0">
+              <a:rPr lang="vi-VN" sz="825" b="0">
                 <a:solidFill>
                   <a:srgbClr val="5F6C7B"/>
                 </a:solidFill>
@@ -27059,9 +27059,9 @@
                 <a:ea typeface="Arial" panose="020B0604020202020204"/>
                 <a:cs typeface="Arial" panose="020B0604020202020204"/>
               </a:rPr>
-              <a:t>Nguồn: ai-models/src/train.py; kết quả chạy --search ngày 27/09/2026</a:t>
-            </a:r>
-            <a:endParaRPr sz="825" b="0">
+              <a:t>Nguồn: README.md · ai-models/colab/03_train.ipynb (snapshot notebook)</a:t>
+            </a:r>
+            <a:endParaRPr lang="vi-VN" sz="825" b="0">
               <a:solidFill>
                 <a:srgbClr val="5F6C7B"/>
               </a:solidFill>
@@ -27415,7 +27415,7 @@
               </a:defRPr>
             </a:pPr>
             <a:r>
-              <a:rPr sz="900" b="0">
+              <a:rPr lang="vi-VN" sz="900" b="0">
                 <a:solidFill>
                   <a:srgbClr val="5F6C7B"/>
                 </a:solidFill>
@@ -27423,9 +27423,9 @@
                 <a:ea typeface="Arial" panose="020B0604020202020204"/>
                 <a:cs typeface="Arial" panose="020B0604020202020204"/>
               </a:rPr>
-              <a:t>Nguồn số liệu: chạy lại train.py --search</a:t>
-            </a:r>
-            <a:endParaRPr sz="900" b="0">
+              <a:t>Nguồn số liệu: README.md · kết quả notebook 03_train</a:t>
+            </a:r>
+            <a:endParaRPr lang="vi-VN" sz="900" b="0">
               <a:solidFill>
                 <a:srgbClr val="5F6C7B"/>
               </a:solidFill>
@@ -27819,7 +27819,7 @@
               </a:defRPr>
             </a:pPr>
             <a:r>
-              <a:rPr sz="1050" b="0">
+              <a:rPr lang="vi-VN" sz="1050" b="0">
                 <a:solidFill>
                   <a:srgbClr val="1D2939"/>
                 </a:solidFill>
@@ -27827,9 +27827,9 @@
                 <a:ea typeface="Arial" panose="020B0604020202020204"/>
                 <a:cs typeface="Arial" panose="020B0604020202020204"/>
               </a:rPr>
-              <a:t>30.660</a:t>
-            </a:r>
-            <a:endParaRPr sz="1050" b="0">
+              <a:t>30.252</a:t>
+            </a:r>
+            <a:endParaRPr lang="vi-VN" sz="1050" b="0">
               <a:solidFill>
                 <a:srgbClr val="1D2939"/>
               </a:solidFill>
@@ -27887,7 +27887,7 @@
               </a:defRPr>
             </a:pPr>
             <a:r>
-              <a:rPr sz="1050" b="0">
+              <a:rPr lang="vi-VN" sz="1050" b="0">
                 <a:solidFill>
                   <a:srgbClr val="1D2939"/>
                 </a:solidFill>
@@ -27895,9 +27895,9 @@
                 <a:ea typeface="Arial" panose="020B0604020202020204"/>
                 <a:cs typeface="Arial" panose="020B0604020202020204"/>
               </a:rPr>
-              <a:t>0,8326</a:t>
-            </a:r>
-            <a:endParaRPr sz="1050" b="0">
+              <a:t>0,8358</a:t>
+            </a:r>
+            <a:endParaRPr lang="vi-VN" sz="1050" b="0">
               <a:solidFill>
                 <a:srgbClr val="1D2939"/>
               </a:solidFill>
@@ -28023,7 +28023,7 @@
               </a:defRPr>
             </a:pPr>
             <a:r>
-              <a:rPr sz="1050" b="0">
+              <a:rPr lang="vi-VN" sz="1050" b="0">
                 <a:solidFill>
                   <a:srgbClr val="1D2939"/>
                 </a:solidFill>
@@ -28031,9 +28031,9 @@
                 <a:ea typeface="Arial" panose="020B0604020202020204"/>
                 <a:cs typeface="Arial" panose="020B0604020202020204"/>
               </a:rPr>
-              <a:t>32.334</a:t>
-            </a:r>
-            <a:endParaRPr sz="1050" b="0">
+              <a:t>31.942</a:t>
+            </a:r>
+            <a:endParaRPr lang="vi-VN" sz="1050" b="0">
               <a:solidFill>
                 <a:srgbClr val="1D2939"/>
               </a:solidFill>
@@ -28091,7 +28091,7 @@
               </a:defRPr>
             </a:pPr>
             <a:r>
-              <a:rPr sz="1050" b="0">
+              <a:rPr lang="vi-VN" sz="1050" b="0">
                 <a:solidFill>
                   <a:srgbClr val="1D2939"/>
                 </a:solidFill>
@@ -28099,9 +28099,9 @@
                 <a:ea typeface="Arial" panose="020B0604020202020204"/>
                 <a:cs typeface="Arial" panose="020B0604020202020204"/>
               </a:rPr>
-              <a:t>0,8078</a:t>
-            </a:r>
-            <a:endParaRPr sz="1050" b="0">
+              <a:t>0,8115</a:t>
+            </a:r>
+            <a:endParaRPr lang="vi-VN" sz="1050" b="0">
               <a:solidFill>
                 <a:srgbClr val="1D2939"/>
               </a:solidFill>
@@ -28227,7 +28227,7 @@
               </a:defRPr>
             </a:pPr>
             <a:r>
-              <a:rPr sz="1050" b="0">
+              <a:rPr lang="vi-VN" sz="1050" b="0">
                 <a:solidFill>
                   <a:srgbClr val="1D2939"/>
                 </a:solidFill>
@@ -28235,9 +28235,9 @@
                 <a:ea typeface="Arial" panose="020B0604020202020204"/>
                 <a:cs typeface="Arial" panose="020B0604020202020204"/>
               </a:rPr>
-              <a:t>40.652</a:t>
-            </a:r>
-            <a:endParaRPr sz="1050" b="0">
+              <a:t>39.990</a:t>
+            </a:r>
+            <a:endParaRPr lang="vi-VN" sz="1050" b="0">
               <a:solidFill>
                 <a:srgbClr val="1D2939"/>
               </a:solidFill>
@@ -28295,7 +28295,7 @@
               </a:defRPr>
             </a:pPr>
             <a:r>
-              <a:rPr sz="1050" b="0">
+              <a:rPr lang="vi-VN" sz="1050" b="0">
                 <a:solidFill>
                   <a:srgbClr val="1D2939"/>
                 </a:solidFill>
@@ -28303,9 +28303,9 @@
                 <a:ea typeface="Arial" panose="020B0604020202020204"/>
                 <a:cs typeface="Arial" panose="020B0604020202020204"/>
               </a:rPr>
-              <a:t>0,7004</a:t>
-            </a:r>
-            <a:endParaRPr sz="1050" b="0">
+              <a:t>0,7179</a:t>
+            </a:r>
+            <a:endParaRPr lang="vi-VN" sz="1050" b="0">
               <a:solidFill>
                 <a:srgbClr val="1D2939"/>
               </a:solidFill>
@@ -28431,7 +28431,7 @@
               </a:defRPr>
             </a:pPr>
             <a:r>
-              <a:rPr sz="1050" b="0">
+              <a:rPr lang="vi-VN" sz="1050" b="0">
                 <a:solidFill>
                   <a:srgbClr val="1D2939"/>
                 </a:solidFill>
@@ -28439,9 +28439,9 @@
                 <a:ea typeface="Arial" panose="020B0604020202020204"/>
                 <a:cs typeface="Arial" panose="020B0604020202020204"/>
               </a:rPr>
-              <a:t>50.899</a:t>
-            </a:r>
-            <a:endParaRPr sz="1050" b="0">
+              <a:t>49.645</a:t>
+            </a:r>
+            <a:endParaRPr lang="vi-VN" sz="1050" b="0">
               <a:solidFill>
                 <a:srgbClr val="1D2939"/>
               </a:solidFill>
@@ -28499,7 +28499,7 @@
               </a:defRPr>
             </a:pPr>
             <a:r>
-              <a:rPr sz="1050" b="0">
+              <a:rPr lang="vi-VN" sz="1050" b="0">
                 <a:solidFill>
                   <a:srgbClr val="1D2939"/>
                 </a:solidFill>
@@ -28507,9 +28507,9 @@
                 <a:ea typeface="Arial" panose="020B0604020202020204"/>
                 <a:cs typeface="Arial" panose="020B0604020202020204"/>
               </a:rPr>
-              <a:t>0,5967</a:t>
-            </a:r>
-            <a:endParaRPr sz="1050" b="0">
+              <a:t>0,6353</a:t>
+            </a:r>
+            <a:endParaRPr lang="vi-VN" sz="1050" b="0">
               <a:solidFill>
                 <a:srgbClr val="1D2939"/>
               </a:solidFill>
@@ -28668,7 +28668,7 @@
               </a:defRPr>
             </a:pPr>
             <a:r>
-              <a:rPr sz="1350" b="1">
+              <a:rPr lang="vi-VN" sz="1350" b="1">
                 <a:solidFill>
                   <a:srgbClr val="102A43"/>
                 </a:solidFill>
@@ -28676,9 +28676,9 @@
                 <a:ea typeface="Arial" panose="020B0604020202020204"/>
                 <a:cs typeface="Arial" panose="020B0604020202020204"/>
               </a:rPr>
-              <a:t>Gradient Boosting có RMSE thấp nhất và R² cao nhất trong lần chạy lại.</a:t>
-            </a:r>
-            <a:endParaRPr sz="1350" b="1">
+              <a:t>Gradient Boosting tốt nhất theo Test RMSE và R² trong snapshot notebook.</a:t>
+            </a:r>
+            <a:endParaRPr lang="vi-VN" sz="1350" b="1">
               <a:solidFill>
                 <a:srgbClr val="102A43"/>
               </a:solidFill>
@@ -28757,7 +28757,7 @@
               </a:defRPr>
             </a:pPr>
             <a:r>
-              <a:rPr sz="825" b="0">
+              <a:rPr lang="vi-VN" sz="825" b="0">
                 <a:solidFill>
                   <a:srgbClr val="5F6C7B"/>
                 </a:solidFill>
@@ -28765,9 +28765,9 @@
                 <a:ea typeface="Arial" panose="020B0604020202020204"/>
                 <a:cs typeface="Arial" panose="020B0604020202020204"/>
               </a:rPr>
-              <a:t>Nguồn: log chạy ai-models/src/train.py --search ngày 27/09/2026</a:t>
-            </a:r>
-            <a:endParaRPr sz="825" b="0">
+              <a:t>Nguồn: README.md · ai-models/colab/03_train.ipynb</a:t>
+            </a:r>
+            <a:endParaRPr lang="vi-VN" sz="825" b="0">
               <a:solidFill>
                 <a:srgbClr val="5F6C7B"/>
               </a:solidFill>

</xml_diff>